<commit_message>
improved examples and description
</commit_message>
<xml_diff>
--- a/slides/5_controller_design.pptx
+++ b/slides/5_controller_design.pptx
@@ -512,7 +512,7 @@
           <a:p>
             <a:fld id="{506E0FD1-891F-4B1E-916D-E9B585160BB8}" type="datetimeFigureOut">
               <a:rPr lang="en-GB" smtClean="0"/>
-              <a:t>05/05/2026</a:t>
+              <a:t>06/05/2026</a:t>
             </a:fld>
             <a:endParaRPr lang="en-GB"/>
           </a:p>
@@ -929,7 +929,7 @@
           <a:p>
             <a:fld id="{D68C3F22-27B2-44E3-9C5F-D08126455F6F}" type="datetime1">
               <a:rPr lang="en-GB" smtClean="0"/>
-              <a:t>05/05/2026</a:t>
+              <a:t>06/05/2026</a:t>
             </a:fld>
             <a:endParaRPr lang="en-GB"/>
           </a:p>
@@ -1129,7 +1129,7 @@
           <a:p>
             <a:fld id="{1CD03846-7BF6-4FB6-A921-FF3379ADBD4C}" type="datetime1">
               <a:rPr lang="en-GB" smtClean="0"/>
-              <a:t>05/05/2026</a:t>
+              <a:t>06/05/2026</a:t>
             </a:fld>
             <a:endParaRPr lang="en-GB"/>
           </a:p>
@@ -1339,7 +1339,7 @@
           <a:p>
             <a:fld id="{99E1B91A-3FD0-4144-9C84-63E9688ED2FE}" type="datetime1">
               <a:rPr lang="en-GB" smtClean="0"/>
-              <a:t>05/05/2026</a:t>
+              <a:t>06/05/2026</a:t>
             </a:fld>
             <a:endParaRPr lang="en-GB"/>
           </a:p>
@@ -1539,7 +1539,7 @@
           <a:p>
             <a:fld id="{5295ED7B-FEAD-4734-819F-93EF4B0EA908}" type="datetime1">
               <a:rPr lang="en-GB" smtClean="0"/>
-              <a:t>05/05/2026</a:t>
+              <a:t>06/05/2026</a:t>
             </a:fld>
             <a:endParaRPr lang="en-GB"/>
           </a:p>
@@ -1815,7 +1815,7 @@
           <a:p>
             <a:fld id="{D2D5D4B4-C926-4B45-8815-1ED8911179A2}" type="datetime1">
               <a:rPr lang="en-GB" smtClean="0"/>
-              <a:t>05/05/2026</a:t>
+              <a:t>06/05/2026</a:t>
             </a:fld>
             <a:endParaRPr lang="en-GB"/>
           </a:p>
@@ -2083,7 +2083,7 @@
           <a:p>
             <a:fld id="{B4C5210A-0E37-4935-93AF-69F21A5F712F}" type="datetime1">
               <a:rPr lang="en-GB" smtClean="0"/>
-              <a:t>05/05/2026</a:t>
+              <a:t>06/05/2026</a:t>
             </a:fld>
             <a:endParaRPr lang="en-GB"/>
           </a:p>
@@ -2498,7 +2498,7 @@
           <a:p>
             <a:fld id="{3D3A6B2F-436C-4691-80E8-9C890E000E9D}" type="datetime1">
               <a:rPr lang="en-GB" smtClean="0"/>
-              <a:t>05/05/2026</a:t>
+              <a:t>06/05/2026</a:t>
             </a:fld>
             <a:endParaRPr lang="en-GB"/>
           </a:p>
@@ -2640,7 +2640,7 @@
           <a:p>
             <a:fld id="{84385F4C-D74B-496F-8D21-97E3549C783B}" type="datetime1">
               <a:rPr lang="en-GB" smtClean="0"/>
-              <a:t>05/05/2026</a:t>
+              <a:t>06/05/2026</a:t>
             </a:fld>
             <a:endParaRPr lang="en-GB"/>
           </a:p>
@@ -2753,7 +2753,7 @@
           <a:p>
             <a:fld id="{0CBDCB32-C241-4703-A832-4EB47BD54E83}" type="datetime1">
               <a:rPr lang="en-GB" smtClean="0"/>
-              <a:t>05/05/2026</a:t>
+              <a:t>06/05/2026</a:t>
             </a:fld>
             <a:endParaRPr lang="en-GB"/>
           </a:p>
@@ -3066,7 +3066,7 @@
           <a:p>
             <a:fld id="{85C150FF-BE95-4D25-A16A-E368A81CBF24}" type="datetime1">
               <a:rPr lang="en-GB" smtClean="0"/>
-              <a:t>05/05/2026</a:t>
+              <a:t>06/05/2026</a:t>
             </a:fld>
             <a:endParaRPr lang="en-GB"/>
           </a:p>
@@ -3355,7 +3355,7 @@
           <a:p>
             <a:fld id="{F3C5DB4B-B349-43C9-A424-BADA723AD9F1}" type="datetime1">
               <a:rPr lang="en-GB" smtClean="0"/>
-              <a:t>05/05/2026</a:t>
+              <a:t>06/05/2026</a:t>
             </a:fld>
             <a:endParaRPr lang="en-GB"/>
           </a:p>
@@ -3598,7 +3598,7 @@
           <a:p>
             <a:fld id="{12632426-0A0C-405F-A3D0-2D11AA44702A}" type="datetime1">
               <a:rPr lang="en-GB" smtClean="0"/>
-              <a:t>05/05/2026</a:t>
+              <a:t>06/05/2026</a:t>
             </a:fld>
             <a:endParaRPr lang="en-GB"/>
           </a:p>
@@ -13395,8 +13395,8 @@
           </a:p>
         </p:txBody>
       </p:sp>
-      <mc:AlternateContent xmlns:mc="http://schemas.openxmlformats.org/markup-compatibility/2006" xmlns:a14="http://schemas.microsoft.com/office/drawing/2010/main">
-        <mc:Choice Requires="a14">
+      <mc:AlternateContent xmlns:mc="http://schemas.openxmlformats.org/markup-compatibility/2006">
+        <mc:Choice xmlns:a14="http://schemas.microsoft.com/office/drawing/2010/main" Requires="a14">
           <p:sp>
             <p:nvSpPr>
               <p:cNvPr id="3" name="Inhaltsplatzhalter 2">
@@ -13413,10 +13413,15 @@
                 <p:ph idx="1"/>
               </p:nvPr>
             </p:nvSpPr>
-            <p:spPr/>
+            <p:spPr>
+              <a:xfrm>
+                <a:off x="838200" y="1690688"/>
+                <a:ext cx="10515600" cy="5030787"/>
+              </a:xfrm>
+            </p:spPr>
             <p:txBody>
               <a:bodyPr>
-                <a:normAutofit fontScale="70000" lnSpcReduction="20000"/>
+                <a:noAutofit/>
               </a:bodyPr>
               <a:lstStyle/>
               <a:p>
@@ -13424,162 +13429,106 @@
                   <a:buNone/>
                 </a:pPr>
                 <a:r>
-                  <a:rPr lang="de-DE" sz="2900" dirty="0"/>
-                  <a:t>Design </a:t>
-                </a:r>
-                <a14:m>
-                  <m:oMath xmlns:m="http://schemas.openxmlformats.org/officeDocument/2006/math">
-                    <m:r>
-                      <a:rPr lang="de-DE" sz="2900" i="1">
-                        <a:latin typeface="Cambria Math" panose="02040503050406030204" pitchFamily="18" charset="0"/>
-                      </a:rPr>
-                      <m:t>𝐶</m:t>
-                    </m:r>
-                    <m:r>
-                      <a:rPr lang="de-DE" sz="2900" i="1">
-                        <a:latin typeface="Cambria Math" panose="02040503050406030204" pitchFamily="18" charset="0"/>
-                      </a:rPr>
-                      <m:t>(</m:t>
-                    </m:r>
-                    <m:r>
-                      <a:rPr lang="de-DE" sz="2900" i="1">
-                        <a:latin typeface="Cambria Math" panose="02040503050406030204" pitchFamily="18" charset="0"/>
-                      </a:rPr>
-                      <m:t>𝑠</m:t>
-                    </m:r>
-                    <m:r>
-                      <a:rPr lang="de-DE" sz="2900" i="1">
-                        <a:latin typeface="Cambria Math" panose="02040503050406030204" pitchFamily="18" charset="0"/>
-                      </a:rPr>
-                      <m:t>)</m:t>
-                    </m:r>
-                  </m:oMath>
-                </a14:m>
-                <a:r>
-                  <a:rPr lang="de-DE" sz="2900" dirty="0"/>
-                  <a:t> </a:t>
-                </a:r>
-                <a:r>
-                  <a:rPr lang="de-DE" sz="2900" dirty="0" err="1"/>
-                  <a:t>from</a:t>
-                </a:r>
-                <a:r>
-                  <a:rPr lang="de-DE" sz="2900" dirty="0"/>
-                  <a:t> a plant </a:t>
-                </a:r>
-                <a:r>
-                  <a:rPr lang="de-DE" sz="2900" dirty="0" err="1"/>
+                  <a:rPr lang="de-DE" sz="2400" dirty="0"/>
+                  <a:t>Invert </a:t>
+                </a:r>
+                <a:r>
+                  <a:rPr lang="de-DE" sz="2400" dirty="0" err="1"/>
+                  <a:t>the</a:t>
+                </a:r>
+                <a:r>
+                  <a:rPr lang="de-DE" sz="2400" dirty="0"/>
+                  <a:t> </a:t>
+                </a:r>
+                <a:r>
+                  <a:rPr lang="de-DE" sz="2400" dirty="0" err="1"/>
                   <a:t>model</a:t>
                 </a:r>
                 <a:r>
-                  <a:rPr lang="de-DE" sz="2900" dirty="0"/>
-                  <a:t> so </a:t>
-                </a:r>
-                <a:r>
-                  <a:rPr lang="de-DE" sz="2900" dirty="0" err="1"/>
-                  <a:t>that</a:t>
-                </a:r>
-                <a:r>
-                  <a:rPr lang="de-DE" sz="2900" dirty="0"/>
-                  <a:t> </a:t>
-                </a:r>
-                <a:r>
-                  <a:rPr lang="de-DE" sz="2900" dirty="0" err="1"/>
-                  <a:t>closed</a:t>
-                </a:r>
-                <a:r>
-                  <a:rPr lang="de-DE" sz="2900" dirty="0"/>
-                  <a:t>-loop </a:t>
-                </a:r>
-                <a:r>
-                  <a:rPr lang="de-DE" sz="2900" dirty="0" err="1"/>
-                  <a:t>response</a:t>
-                </a:r>
-                <a:r>
-                  <a:rPr lang="de-DE" sz="2900" dirty="0"/>
-                  <a:t> </a:t>
-                </a:r>
-                <a:r>
-                  <a:rPr lang="de-DE" sz="2900" dirty="0" err="1"/>
-                  <a:t>behaves</a:t>
-                </a:r>
-                <a:r>
-                  <a:rPr lang="de-DE" sz="2900" dirty="0"/>
-                  <a:t> like a </a:t>
-                </a:r>
-                <a:r>
-                  <a:rPr lang="de-DE" sz="2900" dirty="0" err="1"/>
-                  <a:t>desired</a:t>
-                </a:r>
-                <a:r>
-                  <a:rPr lang="de-DE" sz="2900" dirty="0"/>
-                  <a:t> first-order/</a:t>
-                </a:r>
-                <a:r>
-                  <a:rPr lang="de-DE" sz="2900" dirty="0" err="1"/>
-                  <a:t>second</a:t>
-                </a:r>
-                <a:r>
-                  <a:rPr lang="de-DE" sz="2900" dirty="0"/>
-                  <a:t>-order </a:t>
-                </a:r>
-                <a:r>
-                  <a:rPr lang="de-DE" sz="2900" dirty="0" err="1"/>
-                  <a:t>system</a:t>
-                </a:r>
-                <a:endParaRPr lang="de-DE" sz="2900" dirty="0"/>
+                  <a:rPr lang="de-DE" sz="2400" dirty="0"/>
+                  <a:t>, </a:t>
+                </a:r>
+                <a:r>
+                  <a:rPr lang="de-DE" sz="2400" dirty="0" err="1"/>
+                  <a:t>then</a:t>
+                </a:r>
+                <a:r>
+                  <a:rPr lang="de-DE" sz="2400" dirty="0"/>
+                  <a:t> </a:t>
+                </a:r>
+                <a:r>
+                  <a:rPr lang="de-DE" sz="2400" dirty="0" err="1"/>
+                  <a:t>filter</a:t>
+                </a:r>
+                <a:r>
+                  <a:rPr lang="de-DE" sz="2400" dirty="0"/>
+                  <a:t> </a:t>
+                </a:r>
+                <a:r>
+                  <a:rPr lang="de-DE" sz="2400" dirty="0" err="1"/>
+                  <a:t>it</a:t>
+                </a:r>
+                <a:r>
+                  <a:rPr lang="de-DE" sz="2400" dirty="0"/>
+                  <a:t> </a:t>
+                </a:r>
+                <a:r>
+                  <a:rPr lang="de-DE" sz="2400" dirty="0" err="1"/>
+                  <a:t>to</a:t>
+                </a:r>
+                <a:r>
+                  <a:rPr lang="de-DE" sz="2400" dirty="0"/>
+                  <a:t> </a:t>
+                </a:r>
+                <a:r>
+                  <a:rPr lang="de-DE" sz="2400" dirty="0" err="1"/>
+                  <a:t>get</a:t>
+                </a:r>
+                <a:r>
+                  <a:rPr lang="de-DE" sz="2400" dirty="0"/>
+                  <a:t> a robust and </a:t>
+                </a:r>
+                <a:r>
+                  <a:rPr lang="de-DE" sz="2400" dirty="0" err="1"/>
+                  <a:t>tunable</a:t>
+                </a:r>
+                <a:r>
+                  <a:rPr lang="de-DE" sz="2400" dirty="0"/>
+                  <a:t> </a:t>
+                </a:r>
+                <a:r>
+                  <a:rPr lang="de-DE" sz="2400" dirty="0" err="1"/>
+                  <a:t>controller</a:t>
+                </a:r>
+                <a:endParaRPr lang="de-DE" sz="2400" dirty="0"/>
               </a:p>
               <a:p>
                 <a:pPr marL="0" indent="0">
                   <a:buNone/>
                 </a:pPr>
                 <a:r>
-                  <a:rPr lang="de-DE" sz="2900" dirty="0"/>
-                  <a:t>Explicit loop </a:t>
-                </a:r>
-                <a:r>
-                  <a:rPr lang="de-DE" sz="2900" dirty="0" err="1"/>
-                  <a:t>shaping</a:t>
-                </a:r>
-                <a:r>
-                  <a:rPr lang="de-DE" sz="2900" dirty="0"/>
-                  <a:t>: </a:t>
-                </a:r>
-                <a:r>
-                  <a:rPr lang="de-DE" sz="2900" dirty="0" err="1"/>
-                  <a:t>set</a:t>
-                </a:r>
-                <a:r>
-                  <a:rPr lang="de-DE" sz="2900" dirty="0"/>
-                  <a:t> </a:t>
-                </a:r>
-                <a:r>
-                  <a:rPr lang="de-DE" sz="2900" dirty="0" err="1"/>
-                  <a:t>effective</a:t>
-                </a:r>
-                <a:r>
-                  <a:rPr lang="de-DE" sz="2900" dirty="0"/>
-                  <a:t> </a:t>
+                  <a:rPr lang="de-DE" sz="2400" b="0" dirty="0"/>
+                  <a:t>	</a:t>
                 </a:r>
                 <a14:m>
                   <m:oMath xmlns:m="http://schemas.openxmlformats.org/officeDocument/2006/math">
                     <m:r>
-                      <a:rPr lang="de-DE" sz="2900" i="1">
+                      <a:rPr lang="de-DE" sz="2400" b="0" i="1" smtClean="0">
                         <a:latin typeface="Cambria Math" panose="02040503050406030204" pitchFamily="18" charset="0"/>
                       </a:rPr>
-                      <m:t>𝐿</m:t>
+                      <m:t>𝐶</m:t>
                     </m:r>
                     <m:d>
                       <m:dPr>
                         <m:ctrlPr>
-                          <a:rPr lang="de-DE" sz="2900" i="1">
+                          <a:rPr lang="de-DE" sz="2400" b="0" i="1" smtClean="0">
                             <a:latin typeface="Cambria Math" panose="02040503050406030204" pitchFamily="18" charset="0"/>
                           </a:rPr>
                         </m:ctrlPr>
                       </m:dPr>
                       <m:e>
                         <m:r>
-                          <a:rPr lang="de-DE" sz="2900" i="1">
+                          <a:rPr lang="de-DE" sz="2400" b="0" i="1" smtClean="0">
                             <a:latin typeface="Cambria Math" panose="02040503050406030204" pitchFamily="18" charset="0"/>
                           </a:rPr>
                           <m:t>𝑠</m:t>
@@ -13587,307 +13536,489 @@
                       </m:e>
                     </m:d>
                     <m:r>
-                      <a:rPr lang="de-DE" sz="2900" i="1">
+                      <a:rPr lang="de-DE" sz="2400" b="0" i="1" smtClean="0">
                         <a:latin typeface="Cambria Math" panose="02040503050406030204" pitchFamily="18" charset="0"/>
                       </a:rPr>
                       <m:t>=</m:t>
                     </m:r>
+                    <m:sSup>
+                      <m:sSupPr>
+                        <m:ctrlPr>
+                          <a:rPr lang="de-DE" sz="2400" b="0" i="1" smtClean="0">
+                            <a:latin typeface="Cambria Math" panose="02040503050406030204" pitchFamily="18" charset="0"/>
+                          </a:rPr>
+                        </m:ctrlPr>
+                      </m:sSupPr>
+                      <m:e>
+                        <m:r>
+                          <a:rPr lang="de-DE" sz="2400" b="0" i="1" smtClean="0">
+                            <a:latin typeface="Cambria Math" panose="02040503050406030204" pitchFamily="18" charset="0"/>
+                          </a:rPr>
+                          <m:t>𝐺</m:t>
+                        </m:r>
+                      </m:e>
+                      <m:sup>
+                        <m:r>
+                          <a:rPr lang="de-DE" sz="2400" b="0" i="1" smtClean="0">
+                            <a:latin typeface="Cambria Math" panose="02040503050406030204" pitchFamily="18" charset="0"/>
+                          </a:rPr>
+                          <m:t>−1</m:t>
+                        </m:r>
+                      </m:sup>
+                    </m:sSup>
+                    <m:d>
+                      <m:dPr>
+                        <m:ctrlPr>
+                          <a:rPr lang="de-DE" sz="2400" b="0" i="1" smtClean="0">
+                            <a:latin typeface="Cambria Math" panose="02040503050406030204" pitchFamily="18" charset="0"/>
+                          </a:rPr>
+                        </m:ctrlPr>
+                      </m:dPr>
+                      <m:e>
+                        <m:r>
+                          <a:rPr lang="de-DE" sz="2400" b="0" i="1" smtClean="0">
+                            <a:latin typeface="Cambria Math" panose="02040503050406030204" pitchFamily="18" charset="0"/>
+                          </a:rPr>
+                          <m:t>𝑠</m:t>
+                        </m:r>
+                      </m:e>
+                    </m:d>
                     <m:r>
-                      <a:rPr lang="de-DE" sz="2900" i="1">
+                      <a:rPr lang="de-DE" sz="2400" b="0" i="1" smtClean="0">
                         <a:latin typeface="Cambria Math" panose="02040503050406030204" pitchFamily="18" charset="0"/>
                       </a:rPr>
-                      <m:t>𝐾</m:t>
+                      <m:t>𝐹</m:t>
                     </m:r>
-                    <m:r>
-                      <a:rPr lang="de-DE" sz="2900" i="1">
-                        <a:latin typeface="Cambria Math" panose="02040503050406030204" pitchFamily="18" charset="0"/>
-                      </a:rPr>
-                      <m:t> </m:t>
-                    </m:r>
-                    <m:r>
-                      <a:rPr lang="de-DE" sz="2900" i="1">
-                        <a:latin typeface="Cambria Math" panose="02040503050406030204" pitchFamily="18" charset="0"/>
-                      </a:rPr>
-                      <m:t>𝐺</m:t>
-                    </m:r>
-                    <m:r>
-                      <a:rPr lang="de-DE" sz="2900" i="1">
-                        <a:latin typeface="Cambria Math" panose="02040503050406030204" pitchFamily="18" charset="0"/>
-                      </a:rPr>
-                      <m:t>(</m:t>
-                    </m:r>
-                    <m:r>
-                      <a:rPr lang="de-DE" sz="2900" i="1">
-                        <a:latin typeface="Cambria Math" panose="02040503050406030204" pitchFamily="18" charset="0"/>
-                      </a:rPr>
-                      <m:t>𝑠</m:t>
-                    </m:r>
-                    <m:r>
-                      <a:rPr lang="de-DE" sz="2900" i="1">
-                        <a:latin typeface="Cambria Math" panose="02040503050406030204" pitchFamily="18" charset="0"/>
-                      </a:rPr>
-                      <m:t>)</m:t>
-                    </m:r>
+                    <m:d>
+                      <m:dPr>
+                        <m:ctrlPr>
+                          <a:rPr lang="de-DE" sz="2400" b="0" i="1" smtClean="0">
+                            <a:latin typeface="Cambria Math" panose="02040503050406030204" pitchFamily="18" charset="0"/>
+                          </a:rPr>
+                        </m:ctrlPr>
+                      </m:dPr>
+                      <m:e>
+                        <m:r>
+                          <a:rPr lang="de-DE" sz="2400" b="0" i="1" smtClean="0">
+                            <a:latin typeface="Cambria Math" panose="02040503050406030204" pitchFamily="18" charset="0"/>
+                          </a:rPr>
+                          <m:t>𝑠</m:t>
+                        </m:r>
+                      </m:e>
+                    </m:d>
                   </m:oMath>
                 </a14:m>
                 <a:r>
-                  <a:rPr lang="de-DE" sz="2900" dirty="0"/>
-                  <a:t> </a:t>
-                </a:r>
-                <a:r>
-                  <a:rPr lang="de-DE" sz="2900" dirty="0" err="1"/>
-                  <a:t>to</a:t>
-                </a:r>
-                <a:r>
-                  <a:rPr lang="de-DE" sz="2900" dirty="0"/>
-                  <a:t> </a:t>
-                </a:r>
-                <a:r>
-                  <a:rPr lang="de-DE" sz="2900" dirty="0" err="1"/>
-                  <a:t>achieve</a:t>
-                </a:r>
-                <a:r>
-                  <a:rPr lang="de-DE" sz="2900" dirty="0"/>
-                  <a:t> </a:t>
-                </a:r>
-                <a:r>
-                  <a:rPr lang="de-DE" sz="2900" dirty="0" err="1"/>
-                  <a:t>target</a:t>
-                </a:r>
-                <a:r>
-                  <a:rPr lang="de-DE" sz="2900" dirty="0"/>
-                  <a:t> </a:t>
-                </a:r>
-                <a:r>
-                  <a:rPr lang="de-DE" sz="2900" dirty="0" err="1"/>
-                  <a:t>bandwidth</a:t>
-                </a:r>
-                <a:r>
-                  <a:rPr lang="de-DE" sz="2900" dirty="0"/>
-                  <a:t> and </a:t>
-                </a:r>
-                <a:r>
-                  <a:rPr lang="de-DE" sz="2900" dirty="0" err="1"/>
-                  <a:t>robustness</a:t>
-                </a:r>
-                <a:endParaRPr lang="de-DE" sz="2900" dirty="0"/>
+                  <a:rPr lang="de-DE" sz="2400" b="0" dirty="0"/>
+                  <a:t>,</a:t>
+                </a:r>
               </a:p>
               <a:p>
                 <a:pPr marL="0" indent="0">
                   <a:buNone/>
                 </a:pPr>
-                <a:endParaRPr lang="de-DE" sz="2900" dirty="0"/>
+                <a:r>
+                  <a:rPr lang="de-DE" sz="2400" dirty="0" err="1"/>
+                  <a:t>with</a:t>
+                </a:r>
+                <a:r>
+                  <a:rPr lang="de-DE" sz="2400" dirty="0"/>
+                  <a:t>  a </a:t>
+                </a:r>
+                <a:r>
+                  <a:rPr lang="de-DE" sz="2400" dirty="0" err="1"/>
+                  <a:t>low</a:t>
+                </a:r>
+                <a:r>
+                  <a:rPr lang="de-DE" sz="2400" dirty="0"/>
+                  <a:t>-pass </a:t>
+                </a:r>
+                <a:r>
+                  <a:rPr lang="de-DE" sz="2400" dirty="0" err="1"/>
+                  <a:t>filter</a:t>
+                </a:r>
+                <a:r>
+                  <a:rPr lang="de-DE" sz="2400" dirty="0"/>
+                  <a:t> </a:t>
+                </a:r>
+                <a14:m>
+                  <m:oMath xmlns:m="http://schemas.openxmlformats.org/officeDocument/2006/math">
+                    <m:r>
+                      <a:rPr lang="de-DE" sz="2400" i="1">
+                        <a:latin typeface="Cambria Math" panose="02040503050406030204" pitchFamily="18" charset="0"/>
+                      </a:rPr>
+                      <m:t>𝐹</m:t>
+                    </m:r>
+                    <m:d>
+                      <m:dPr>
+                        <m:ctrlPr>
+                          <a:rPr lang="de-DE" sz="2400" i="1">
+                            <a:latin typeface="Cambria Math" panose="02040503050406030204" pitchFamily="18" charset="0"/>
+                          </a:rPr>
+                        </m:ctrlPr>
+                      </m:dPr>
+                      <m:e>
+                        <m:r>
+                          <a:rPr lang="de-DE" sz="2400" i="1">
+                            <a:latin typeface="Cambria Math" panose="02040503050406030204" pitchFamily="18" charset="0"/>
+                          </a:rPr>
+                          <m:t>𝑠</m:t>
+                        </m:r>
+                      </m:e>
+                    </m:d>
+                  </m:oMath>
+                </a14:m>
+                <a:r>
+                  <a:rPr lang="de-DE" sz="2400" dirty="0"/>
+                  <a:t>, e.g., </a:t>
+                </a:r>
+                <a14:m>
+                  <m:oMath xmlns:m="http://schemas.openxmlformats.org/officeDocument/2006/math">
+                    <m:r>
+                      <a:rPr lang="de-DE" sz="2400" i="1">
+                        <a:latin typeface="Cambria Math" panose="02040503050406030204" pitchFamily="18" charset="0"/>
+                      </a:rPr>
+                      <m:t>𝐹</m:t>
+                    </m:r>
+                    <m:d>
+                      <m:dPr>
+                        <m:ctrlPr>
+                          <a:rPr lang="de-DE" sz="2400" i="1">
+                            <a:latin typeface="Cambria Math" panose="02040503050406030204" pitchFamily="18" charset="0"/>
+                          </a:rPr>
+                        </m:ctrlPr>
+                      </m:dPr>
+                      <m:e>
+                        <m:r>
+                          <a:rPr lang="de-DE" sz="2400" i="1">
+                            <a:latin typeface="Cambria Math" panose="02040503050406030204" pitchFamily="18" charset="0"/>
+                          </a:rPr>
+                          <m:t>𝑠</m:t>
+                        </m:r>
+                      </m:e>
+                    </m:d>
+                    <m:r>
+                      <a:rPr lang="de-DE" sz="2400" b="0" i="1" smtClean="0">
+                        <a:latin typeface="Cambria Math" panose="02040503050406030204" pitchFamily="18" charset="0"/>
+                      </a:rPr>
+                      <m:t>=</m:t>
+                    </m:r>
+                    <m:f>
+                      <m:fPr>
+                        <m:ctrlPr>
+                          <a:rPr lang="de-DE" sz="2400" b="0" i="1" smtClean="0">
+                            <a:latin typeface="Cambria Math" panose="02040503050406030204" pitchFamily="18" charset="0"/>
+                          </a:rPr>
+                        </m:ctrlPr>
+                      </m:fPr>
+                      <m:num>
+                        <m:r>
+                          <a:rPr lang="de-DE" sz="2400" b="0" i="1" smtClean="0">
+                            <a:latin typeface="Cambria Math" panose="02040503050406030204" pitchFamily="18" charset="0"/>
+                          </a:rPr>
+                          <m:t>1</m:t>
+                        </m:r>
+                      </m:num>
+                      <m:den>
+                        <m:r>
+                          <a:rPr lang="de-DE" sz="2400" b="0" i="1" smtClean="0">
+                            <a:latin typeface="Cambria Math" panose="02040503050406030204" pitchFamily="18" charset="0"/>
+                            <a:ea typeface="Cambria Math" panose="02040503050406030204" pitchFamily="18" charset="0"/>
+                          </a:rPr>
+                          <m:t>𝜆</m:t>
+                        </m:r>
+                        <m:r>
+                          <a:rPr lang="de-DE" sz="2400" b="0" i="1" smtClean="0">
+                            <a:latin typeface="Cambria Math" panose="02040503050406030204" pitchFamily="18" charset="0"/>
+                            <a:ea typeface="Cambria Math" panose="02040503050406030204" pitchFamily="18" charset="0"/>
+                          </a:rPr>
+                          <m:t>∙</m:t>
+                        </m:r>
+                        <m:r>
+                          <a:rPr lang="de-DE" sz="2400" b="0" i="1" smtClean="0">
+                            <a:latin typeface="Cambria Math" panose="02040503050406030204" pitchFamily="18" charset="0"/>
+                            <a:ea typeface="Cambria Math" panose="02040503050406030204" pitchFamily="18" charset="0"/>
+                          </a:rPr>
+                          <m:t>𝑠</m:t>
+                        </m:r>
+                        <m:r>
+                          <a:rPr lang="de-DE" sz="2400" b="0" i="1" smtClean="0">
+                            <a:latin typeface="Cambria Math" panose="02040503050406030204" pitchFamily="18" charset="0"/>
+                            <a:ea typeface="Cambria Math" panose="02040503050406030204" pitchFamily="18" charset="0"/>
+                          </a:rPr>
+                          <m:t>+1</m:t>
+                        </m:r>
+                      </m:den>
+                    </m:f>
+                  </m:oMath>
+                </a14:m>
+                <a:endParaRPr lang="de-DE" sz="2400" dirty="0"/>
               </a:p>
               <a:p>
                 <a:pPr marL="0" indent="0">
                   <a:buNone/>
                 </a:pPr>
-                <a:r>
-                  <a:rPr lang="de-DE" sz="2900" dirty="0"/>
-                  <a:t>Advantages:</a:t>
-                </a:r>
+                <a:endParaRPr lang="de-DE" sz="2400" dirty="0"/>
               </a:p>
               <a:p>
-                <a:r>
-                  <a:rPr lang="de-DE" sz="2900" dirty="0" err="1"/>
-                  <a:t>systematic</a:t>
-                </a:r>
-                <a:r>
-                  <a:rPr lang="de-DE" sz="2900" dirty="0"/>
-                  <a:t> </a:t>
-                </a:r>
-                <a:r>
-                  <a:rPr lang="de-DE" sz="2900" dirty="0" err="1"/>
-                  <a:t>controller</a:t>
-                </a:r>
-                <a:r>
-                  <a:rPr lang="de-DE" sz="2900" dirty="0"/>
-                  <a:t> design </a:t>
-                </a:r>
-                <a:r>
-                  <a:rPr lang="de-DE" sz="2900" dirty="0" err="1"/>
-                  <a:t>based</a:t>
-                </a:r>
-                <a:r>
-                  <a:rPr lang="de-DE" sz="2900" dirty="0"/>
-                  <a:t> on plant </a:t>
-                </a:r>
-                <a:r>
-                  <a:rPr lang="de-DE" sz="2900" dirty="0" err="1"/>
-                  <a:t>model</a:t>
-                </a:r>
-                <a:endParaRPr lang="de-DE" sz="2900" dirty="0"/>
+                <a14:m>
+                  <m:oMath xmlns:m="http://schemas.openxmlformats.org/officeDocument/2006/math">
+                    <m:sSup>
+                      <m:sSupPr>
+                        <m:ctrlPr>
+                          <a:rPr lang="de-DE" sz="2400" i="1">
+                            <a:latin typeface="Cambria Math" panose="02040503050406030204" pitchFamily="18" charset="0"/>
+                          </a:rPr>
+                        </m:ctrlPr>
+                      </m:sSupPr>
+                      <m:e>
+                        <m:r>
+                          <a:rPr lang="de-DE" sz="2400" i="1">
+                            <a:latin typeface="Cambria Math" panose="02040503050406030204" pitchFamily="18" charset="0"/>
+                          </a:rPr>
+                          <m:t>𝐺</m:t>
+                        </m:r>
+                      </m:e>
+                      <m:sup>
+                        <m:r>
+                          <a:rPr lang="de-DE" sz="2400" i="1">
+                            <a:latin typeface="Cambria Math" panose="02040503050406030204" pitchFamily="18" charset="0"/>
+                          </a:rPr>
+                          <m:t>−1</m:t>
+                        </m:r>
+                      </m:sup>
+                    </m:sSup>
+                    <m:d>
+                      <m:dPr>
+                        <m:ctrlPr>
+                          <a:rPr lang="de-DE" sz="2400" i="1">
+                            <a:latin typeface="Cambria Math" panose="02040503050406030204" pitchFamily="18" charset="0"/>
+                          </a:rPr>
+                        </m:ctrlPr>
+                      </m:dPr>
+                      <m:e>
+                        <m:r>
+                          <a:rPr lang="de-DE" sz="2400" i="1">
+                            <a:latin typeface="Cambria Math" panose="02040503050406030204" pitchFamily="18" charset="0"/>
+                          </a:rPr>
+                          <m:t>𝑠</m:t>
+                        </m:r>
+                      </m:e>
+                    </m:d>
+                  </m:oMath>
+                </a14:m>
+                <a:r>
+                  <a:rPr lang="de-DE" sz="2400" dirty="0"/>
+                  <a:t> </a:t>
+                </a:r>
+                <a:r>
+                  <a:rPr lang="de-DE" sz="2400" dirty="0" err="1"/>
+                  <a:t>cancels</a:t>
+                </a:r>
+                <a:r>
+                  <a:rPr lang="de-DE" sz="2400" dirty="0"/>
+                  <a:t> plant </a:t>
+                </a:r>
+                <a:r>
+                  <a:rPr lang="de-DE" sz="2400" dirty="0" err="1"/>
+                  <a:t>dynamics</a:t>
+                </a:r>
+                <a:r>
+                  <a:rPr lang="de-DE" sz="2400" dirty="0"/>
+                  <a:t> (</a:t>
+                </a:r>
+                <a:r>
+                  <a:rPr lang="de-DE" sz="2400" dirty="0" err="1"/>
+                  <a:t>performance</a:t>
+                </a:r>
+                <a:r>
+                  <a:rPr lang="de-DE" sz="2400" dirty="0"/>
+                  <a:t>)</a:t>
+                </a:r>
               </a:p>
               <a:p>
-                <a:r>
-                  <a:rPr lang="de-DE" sz="2900" dirty="0"/>
-                  <a:t>explicit trade-off </a:t>
-                </a:r>
-                <a:r>
-                  <a:rPr lang="de-DE" sz="2900" dirty="0" err="1"/>
-                  <a:t>between</a:t>
-                </a:r>
-                <a:r>
-                  <a:rPr lang="de-DE" sz="2900" dirty="0"/>
-                  <a:t> </a:t>
-                </a:r>
-                <a:r>
-                  <a:rPr lang="de-DE" sz="2900" dirty="0" err="1"/>
-                  <a:t>performance</a:t>
-                </a:r>
-                <a:r>
-                  <a:rPr lang="de-DE" sz="2900" dirty="0"/>
-                  <a:t> and </a:t>
-                </a:r>
-                <a:r>
-                  <a:rPr lang="de-DE" sz="2900" dirty="0" err="1"/>
+                <a14:m>
+                  <m:oMath xmlns:m="http://schemas.openxmlformats.org/officeDocument/2006/math">
+                    <m:r>
+                      <a:rPr lang="de-DE" sz="2400" i="1">
+                        <a:latin typeface="Cambria Math" panose="02040503050406030204" pitchFamily="18" charset="0"/>
+                      </a:rPr>
+                      <m:t>𝐹</m:t>
+                    </m:r>
+                    <m:d>
+                      <m:dPr>
+                        <m:ctrlPr>
+                          <a:rPr lang="de-DE" sz="2400" i="1">
+                            <a:latin typeface="Cambria Math" panose="02040503050406030204" pitchFamily="18" charset="0"/>
+                          </a:rPr>
+                        </m:ctrlPr>
+                      </m:dPr>
+                      <m:e>
+                        <m:r>
+                          <a:rPr lang="de-DE" sz="2400" i="1">
+                            <a:latin typeface="Cambria Math" panose="02040503050406030204" pitchFamily="18" charset="0"/>
+                          </a:rPr>
+                          <m:t>𝑠</m:t>
+                        </m:r>
+                      </m:e>
+                    </m:d>
+                  </m:oMath>
+                </a14:m>
+                <a:r>
+                  <a:rPr lang="de-DE" sz="2400" dirty="0"/>
+                  <a:t> </a:t>
+                </a:r>
+                <a:r>
+                  <a:rPr lang="de-DE" sz="2400" dirty="0" err="1"/>
+                  <a:t>limits</a:t>
+                </a:r>
+                <a:r>
+                  <a:rPr lang="de-DE" sz="2400" dirty="0"/>
+                  <a:t> </a:t>
+                </a:r>
+                <a:r>
+                  <a:rPr lang="de-DE" sz="2400" dirty="0" err="1"/>
+                  <a:t>bandwidth</a:t>
+                </a:r>
+                <a:r>
+                  <a:rPr lang="de-DE" sz="2400" dirty="0"/>
+                  <a:t> (</a:t>
+                </a:r>
+                <a:r>
+                  <a:rPr lang="de-DE" sz="2400" dirty="0" err="1"/>
                   <a:t>robustness</a:t>
                 </a:r>
-                <a:endParaRPr lang="de-DE" sz="2900" dirty="0"/>
+                <a:r>
+                  <a:rPr lang="de-DE" sz="2400" dirty="0"/>
+                  <a:t>)</a:t>
+                </a:r>
               </a:p>
               <a:p>
-                <a:r>
-                  <a:rPr lang="de-DE" sz="2900" dirty="0" err="1"/>
-                  <a:t>often</a:t>
-                </a:r>
-                <a:r>
-                  <a:rPr lang="de-DE" sz="2900" dirty="0"/>
-                  <a:t> </a:t>
-                </a:r>
-                <a:r>
-                  <a:rPr lang="de-DE" sz="2900" dirty="0" err="1"/>
-                  <a:t>leads</a:t>
-                </a:r>
-                <a:r>
-                  <a:rPr lang="de-DE" sz="2900" dirty="0"/>
-                  <a:t> </a:t>
-                </a:r>
-                <a:r>
-                  <a:rPr lang="de-DE" sz="2900" dirty="0" err="1"/>
-                  <a:t>to</a:t>
-                </a:r>
-                <a:r>
-                  <a:rPr lang="de-DE" sz="2900" dirty="0"/>
-                  <a:t> simple PI </a:t>
-                </a:r>
-                <a:r>
-                  <a:rPr lang="de-DE" sz="2900" dirty="0" err="1"/>
-                  <a:t>or</a:t>
-                </a:r>
-                <a:r>
-                  <a:rPr lang="de-DE" sz="2900" dirty="0"/>
-                  <a:t> PID </a:t>
-                </a:r>
-                <a:r>
-                  <a:rPr lang="de-DE" sz="2900" dirty="0" err="1"/>
-                  <a:t>structures</a:t>
-                </a:r>
-                <a:endParaRPr lang="de-DE" sz="2900" dirty="0"/>
+                <a14:m>
+                  <m:oMath xmlns:m="http://schemas.openxmlformats.org/officeDocument/2006/math">
+                    <m:r>
+                      <a:rPr lang="de-DE" sz="2400" i="1">
+                        <a:latin typeface="Cambria Math" panose="02040503050406030204" pitchFamily="18" charset="0"/>
+                        <a:ea typeface="Cambria Math" panose="02040503050406030204" pitchFamily="18" charset="0"/>
+                      </a:rPr>
+                      <m:t>𝜆</m:t>
+                    </m:r>
+                  </m:oMath>
+                </a14:m>
+                <a:r>
+                  <a:rPr lang="de-DE" sz="2400" dirty="0"/>
+                  <a:t>: tuning </a:t>
+                </a:r>
+                <a:r>
+                  <a:rPr lang="de-DE" sz="2400" dirty="0" err="1"/>
+                  <a:t>parameter</a:t>
+                </a:r>
+                <a:r>
+                  <a:rPr lang="de-DE" sz="2400" dirty="0"/>
+                  <a:t> </a:t>
+                </a:r>
+                <a:r>
+                  <a:rPr lang="de-DE" sz="2400" dirty="0" err="1"/>
+                  <a:t>controlling</a:t>
+                </a:r>
+                <a:r>
+                  <a:rPr lang="de-DE" sz="2400" dirty="0"/>
+                  <a:t> trade-off</a:t>
+                </a:r>
+                <a:br>
+                  <a:rPr lang="de-DE" sz="2400" dirty="0"/>
+                </a:br>
+                <a:endParaRPr lang="de-DE" sz="2400" dirty="0"/>
               </a:p>
               <a:p>
                 <a:pPr marL="0" indent="0">
                   <a:buNone/>
                 </a:pPr>
-                <a:endParaRPr lang="de-DE" sz="2900" dirty="0"/>
+                <a:r>
+                  <a:rPr lang="de-DE" sz="2400" dirty="0">
+                    <a:sym typeface="Wingdings" pitchFamily="2" charset="2"/>
+                  </a:rPr>
+                  <a:t> </a:t>
+                </a:r>
+                <a:r>
+                  <a:rPr lang="de-DE" sz="2400" dirty="0" err="1"/>
+                  <a:t>Closed</a:t>
+                </a:r>
+                <a:r>
+                  <a:rPr lang="de-DE" sz="2400" dirty="0"/>
+                  <a:t>-loop </a:t>
+                </a:r>
+                <a:r>
+                  <a:rPr lang="de-DE" sz="2400" dirty="0" err="1"/>
+                  <a:t>behaves</a:t>
+                </a:r>
+                <a:r>
+                  <a:rPr lang="de-DE" sz="2400" dirty="0"/>
+                  <a:t> like a simple </a:t>
+                </a:r>
+                <a:r>
+                  <a:rPr lang="de-DE" sz="2400" dirty="0" err="1"/>
+                  <a:t>low</a:t>
+                </a:r>
+                <a:r>
+                  <a:rPr lang="de-DE" sz="2400" dirty="0"/>
+                  <a:t>-order </a:t>
+                </a:r>
+                <a:r>
+                  <a:rPr lang="de-DE" sz="2400" dirty="0" err="1"/>
+                  <a:t>system</a:t>
+                </a:r>
+                <a:r>
+                  <a:rPr lang="de-DE" sz="2400" dirty="0"/>
+                  <a:t>:</a:t>
+                </a:r>
               </a:p>
               <a:p>
-                <a:pPr marL="0" indent="0">
-                  <a:buNone/>
-                </a:pPr>
-                <a:r>
-                  <a:rPr lang="de-DE" sz="2900" dirty="0" err="1"/>
-                  <a:t>Limitations</a:t>
-                </a:r>
-                <a:r>
-                  <a:rPr lang="de-DE" sz="2900" dirty="0"/>
-                  <a:t>:</a:t>
-                </a:r>
+                <a:r>
+                  <a:rPr lang="de-DE" sz="2400" dirty="0"/>
+                  <a:t>first-order: smooth, </a:t>
+                </a:r>
+                <a:r>
+                  <a:rPr lang="de-DE" sz="2400" dirty="0" err="1"/>
+                  <a:t>no</a:t>
+                </a:r>
+                <a:r>
+                  <a:rPr lang="de-DE" sz="2400" dirty="0"/>
+                  <a:t> </a:t>
+                </a:r>
+                <a:r>
+                  <a:rPr lang="de-DE" sz="2400" dirty="0" err="1"/>
+                  <a:t>overshoot</a:t>
+                </a:r>
+                <a:endParaRPr lang="de-DE" sz="2400" dirty="0"/>
               </a:p>
               <a:p>
                 <a:r>
-                  <a:rPr lang="de-DE" sz="2900" dirty="0" err="1"/>
-                  <a:t>requires</a:t>
-                </a:r>
-                <a:r>
-                  <a:rPr lang="de-DE" sz="2900" dirty="0"/>
-                  <a:t> </a:t>
-                </a:r>
-                <a:r>
-                  <a:rPr lang="de-DE" sz="2900" dirty="0" err="1"/>
-                  <a:t>reasonably</a:t>
-                </a:r>
-                <a:r>
-                  <a:rPr lang="de-DE" sz="2900" dirty="0"/>
-                  <a:t> </a:t>
-                </a:r>
-                <a:r>
-                  <a:rPr lang="de-DE" sz="2900" dirty="0" err="1"/>
-                  <a:t>accurate</a:t>
-                </a:r>
-                <a:r>
-                  <a:rPr lang="de-DE" sz="2900" dirty="0"/>
-                  <a:t> plant </a:t>
-                </a:r>
-                <a:r>
-                  <a:rPr lang="de-DE" sz="2900" dirty="0" err="1"/>
-                  <a:t>model</a:t>
-                </a:r>
-                <a:endParaRPr lang="de-DE" sz="2900" dirty="0"/>
-              </a:p>
-              <a:p>
-                <a:r>
-                  <a:rPr lang="de-DE" sz="2900" dirty="0" err="1"/>
-                  <a:t>performance</a:t>
-                </a:r>
-                <a:r>
-                  <a:rPr lang="de-DE" sz="2900" dirty="0"/>
-                  <a:t> </a:t>
-                </a:r>
-                <a:r>
-                  <a:rPr lang="de-DE" sz="2900" dirty="0" err="1"/>
-                  <a:t>degrades</a:t>
-                </a:r>
-                <a:r>
-                  <a:rPr lang="de-DE" sz="2900" dirty="0"/>
-                  <a:t> </a:t>
-                </a:r>
-                <a:r>
-                  <a:rPr lang="de-DE" sz="2900" dirty="0" err="1"/>
-                  <a:t>if</a:t>
-                </a:r>
-                <a:r>
-                  <a:rPr lang="de-DE" sz="2900" dirty="0"/>
-                  <a:t> </a:t>
-                </a:r>
-                <a:r>
-                  <a:rPr lang="de-DE" sz="2900" dirty="0" err="1"/>
-                  <a:t>model</a:t>
-                </a:r>
-                <a:r>
-                  <a:rPr lang="de-DE" sz="2900" dirty="0"/>
-                  <a:t> </a:t>
-                </a:r>
-                <a:r>
-                  <a:rPr lang="de-DE" sz="2900" dirty="0" err="1"/>
-                  <a:t>mismatch</a:t>
-                </a:r>
-                <a:r>
-                  <a:rPr lang="de-DE" sz="2900" dirty="0"/>
-                  <a:t> </a:t>
-                </a:r>
-                <a:r>
-                  <a:rPr lang="de-DE" sz="2900" dirty="0" err="1"/>
-                  <a:t>is</a:t>
-                </a:r>
-                <a:r>
-                  <a:rPr lang="de-DE" sz="2900" dirty="0"/>
-                  <a:t> large</a:t>
-                </a:r>
+                  <a:rPr lang="de-DE" sz="2400" dirty="0" err="1"/>
+                  <a:t>second</a:t>
+                </a:r>
+                <a:r>
+                  <a:rPr lang="de-DE" sz="2400" dirty="0"/>
+                  <a:t>-order: </a:t>
+                </a:r>
+                <a:r>
+                  <a:rPr lang="de-DE" sz="2400" dirty="0" err="1"/>
+                  <a:t>faster</a:t>
+                </a:r>
+                <a:r>
+                  <a:rPr lang="de-DE" sz="2400" dirty="0"/>
+                  <a:t>, possible </a:t>
+                </a:r>
+                <a:r>
+                  <a:rPr lang="de-DE" sz="2400" dirty="0" err="1"/>
+                  <a:t>oscillation</a:t>
+                </a:r>
+                <a:endParaRPr lang="de-DE" sz="2400" dirty="0"/>
               </a:p>
             </p:txBody>
           </p:sp>
         </mc:Choice>
-        <mc:Fallback xmlns="">
+        <mc:Fallback>
           <p:sp>
             <p:nvSpPr>
               <p:cNvPr id="3" name="Inhaltsplatzhalter 2">
@@ -13905,10 +14036,14 @@
               </p:nvPr>
             </p:nvSpPr>
             <p:spPr>
+              <a:xfrm>
+                <a:off x="838200" y="1690688"/>
+                <a:ext cx="10515600" cy="5030787"/>
+              </a:xfrm>
               <a:blipFill>
                 <a:blip r:embed="rId2"/>
                 <a:stretch>
-                  <a:fillRect l="-724" t="-2035"/>
+                  <a:fillRect l="-965" t="-1508" b="-2010"/>
                 </a:stretch>
               </a:blipFill>
             </p:spPr>
@@ -13956,6 +14091,383 @@
           </a:p>
         </p:txBody>
       </p:sp>
+      <p:sp>
+        <p:nvSpPr>
+          <p:cNvPr id="6" name="Textfeld 5">
+            <a:extLst>
+              <a:ext uri="{FF2B5EF4-FFF2-40B4-BE49-F238E27FC236}">
+                <a16:creationId xmlns:a16="http://schemas.microsoft.com/office/drawing/2014/main" id="{D0B3A41B-2823-0731-704A-529AF3672B58}"/>
+              </a:ext>
+            </a:extLst>
+          </p:cNvPr>
+          <p:cNvSpPr txBox="1"/>
+          <p:nvPr/>
+        </p:nvSpPr>
+        <p:spPr>
+          <a:xfrm>
+            <a:off x="5105400" y="566241"/>
+            <a:ext cx="6568440" cy="461665"/>
+          </a:xfrm>
+          <a:prstGeom prst="rect">
+            <a:avLst/>
+          </a:prstGeom>
+          <a:noFill/>
+          <a:ln>
+            <a:solidFill>
+              <a:schemeClr val="tx1"/>
+            </a:solidFill>
+          </a:ln>
+        </p:spPr>
+        <p:txBody>
+          <a:bodyPr wrap="square">
+            <a:spAutoFit/>
+          </a:bodyPr>
+          <a:lstStyle/>
+          <a:p>
+            <a:pPr>
+              <a:buNone/>
+            </a:pPr>
+            <a:r>
+              <a:rPr lang="de-DE" sz="2400" dirty="0" err="1"/>
+              <a:t>directly</a:t>
+            </a:r>
+            <a:r>
+              <a:rPr lang="de-DE" sz="2400" dirty="0"/>
+              <a:t> </a:t>
+            </a:r>
+            <a:r>
+              <a:rPr lang="de-DE" sz="2400" dirty="0" err="1"/>
+              <a:t>shapes</a:t>
+            </a:r>
+            <a:r>
+              <a:rPr lang="de-DE" sz="2400" dirty="0"/>
+              <a:t> </a:t>
+            </a:r>
+            <a:r>
+              <a:rPr lang="de-DE" sz="2400" dirty="0" err="1"/>
+              <a:t>the</a:t>
+            </a:r>
+            <a:r>
+              <a:rPr lang="de-DE" sz="2400" dirty="0"/>
+              <a:t> </a:t>
+            </a:r>
+            <a:r>
+              <a:rPr lang="de-DE" sz="2400" dirty="0" err="1"/>
+              <a:t>closed</a:t>
+            </a:r>
+            <a:r>
+              <a:rPr lang="de-DE" sz="2400" dirty="0"/>
+              <a:t>-loop </a:t>
+            </a:r>
+            <a:r>
+              <a:rPr lang="de-DE" sz="2400" dirty="0" err="1"/>
+              <a:t>transfer</a:t>
+            </a:r>
+            <a:r>
+              <a:rPr lang="de-DE" sz="2400" dirty="0"/>
+              <a:t> </a:t>
+            </a:r>
+            <a:r>
+              <a:rPr lang="de-DE" sz="2400" dirty="0" err="1"/>
+              <a:t>function</a:t>
+            </a:r>
+            <a:endParaRPr lang="de-DE" sz="2400" dirty="0"/>
+          </a:p>
+        </p:txBody>
+      </p:sp>
+      <mc:AlternateContent xmlns:mc="http://schemas.openxmlformats.org/markup-compatibility/2006">
+        <mc:Choice xmlns:a14="http://schemas.microsoft.com/office/drawing/2010/main" Requires="a14">
+          <p:sp>
+            <p:nvSpPr>
+              <p:cNvPr id="7" name="Textfeld 6">
+                <a:extLst>
+                  <a:ext uri="{FF2B5EF4-FFF2-40B4-BE49-F238E27FC236}">
+                    <a16:creationId xmlns:a16="http://schemas.microsoft.com/office/drawing/2014/main" id="{D7F6EAC6-0F4E-33E2-EF9C-83D1726BD234}"/>
+                  </a:ext>
+                </a:extLst>
+              </p:cNvPr>
+              <p:cNvSpPr txBox="1"/>
+              <p:nvPr/>
+            </p:nvSpPr>
+            <p:spPr>
+              <a:xfrm>
+                <a:off x="7376160" y="6002327"/>
+                <a:ext cx="3977640" cy="461665"/>
+              </a:xfrm>
+              <a:prstGeom prst="rect">
+                <a:avLst/>
+              </a:prstGeom>
+              <a:noFill/>
+            </p:spPr>
+            <p:txBody>
+              <a:bodyPr wrap="square" rtlCol="0">
+                <a:spAutoFit/>
+              </a:bodyPr>
+              <a:lstStyle/>
+              <a:p>
+                <a:r>
+                  <a:rPr lang="de-DE" sz="2400" dirty="0" err="1"/>
+                  <a:t>depending</a:t>
+                </a:r>
+                <a:r>
+                  <a:rPr lang="de-DE" sz="2400" dirty="0"/>
+                  <a:t> on </a:t>
+                </a:r>
+                <a:r>
+                  <a:rPr lang="de-DE" sz="2400" dirty="0" err="1"/>
+                  <a:t>choice</a:t>
+                </a:r>
+                <a:r>
+                  <a:rPr lang="de-DE" sz="2400" dirty="0"/>
+                  <a:t> </a:t>
+                </a:r>
+                <a:r>
+                  <a:rPr lang="de-DE" sz="2400" dirty="0" err="1"/>
+                  <a:t>of</a:t>
+                </a:r>
+                <a:r>
+                  <a:rPr lang="de-DE" sz="2400" dirty="0"/>
+                  <a:t> </a:t>
+                </a:r>
+                <a14:m>
+                  <m:oMath xmlns:m="http://schemas.openxmlformats.org/officeDocument/2006/math">
+                    <m:r>
+                      <a:rPr lang="de-DE" sz="2400" i="1">
+                        <a:latin typeface="Cambria Math" panose="02040503050406030204" pitchFamily="18" charset="0"/>
+                      </a:rPr>
+                      <m:t>𝐹</m:t>
+                    </m:r>
+                    <m:d>
+                      <m:dPr>
+                        <m:ctrlPr>
+                          <a:rPr lang="de-DE" sz="2400" i="1">
+                            <a:latin typeface="Cambria Math" panose="02040503050406030204" pitchFamily="18" charset="0"/>
+                          </a:rPr>
+                        </m:ctrlPr>
+                      </m:dPr>
+                      <m:e>
+                        <m:r>
+                          <a:rPr lang="de-DE" sz="2400" i="1">
+                            <a:latin typeface="Cambria Math" panose="02040503050406030204" pitchFamily="18" charset="0"/>
+                          </a:rPr>
+                          <m:t>𝑠</m:t>
+                        </m:r>
+                      </m:e>
+                    </m:d>
+                  </m:oMath>
+                </a14:m>
+                <a:endParaRPr lang="de-DE" sz="2400" dirty="0"/>
+              </a:p>
+            </p:txBody>
+          </p:sp>
+        </mc:Choice>
+        <mc:Fallback>
+          <p:sp>
+            <p:nvSpPr>
+              <p:cNvPr id="7" name="Textfeld 6">
+                <a:extLst>
+                  <a:ext uri="{FF2B5EF4-FFF2-40B4-BE49-F238E27FC236}">
+                    <a16:creationId xmlns:a16="http://schemas.microsoft.com/office/drawing/2014/main" id="{D7F6EAC6-0F4E-33E2-EF9C-83D1726BD234}"/>
+                  </a:ext>
+                </a:extLst>
+              </p:cNvPr>
+              <p:cNvSpPr txBox="1">
+                <a:spLocks noRot="1" noChangeAspect="1" noMove="1" noResize="1" noEditPoints="1" noAdjustHandles="1" noChangeArrowheads="1" noChangeShapeType="1" noTextEdit="1"/>
+              </p:cNvSpPr>
+              <p:nvPr/>
+            </p:nvSpPr>
+            <p:spPr>
+              <a:xfrm>
+                <a:off x="7376160" y="6002327"/>
+                <a:ext cx="3977640" cy="461665"/>
+              </a:xfrm>
+              <a:prstGeom prst="rect">
+                <a:avLst/>
+              </a:prstGeom>
+              <a:blipFill>
+                <a:blip r:embed="rId3"/>
+                <a:stretch>
+                  <a:fillRect l="-2222" t="-10811" b="-29730"/>
+                </a:stretch>
+              </a:blipFill>
+            </p:spPr>
+            <p:txBody>
+              <a:bodyPr/>
+              <a:lstStyle/>
+              <a:p>
+                <a:r>
+                  <a:rPr lang="de-DE">
+                    <a:noFill/>
+                  </a:rPr>
+                  <a:t> </a:t>
+                </a:r>
+              </a:p>
+            </p:txBody>
+          </p:sp>
+        </mc:Fallback>
+      </mc:AlternateContent>
+      <p:sp>
+        <p:nvSpPr>
+          <p:cNvPr id="8" name="Geschweifte Klammer rechts 7">
+            <a:extLst>
+              <a:ext uri="{FF2B5EF4-FFF2-40B4-BE49-F238E27FC236}">
+                <a16:creationId xmlns:a16="http://schemas.microsoft.com/office/drawing/2014/main" id="{163653C3-969D-F1D0-57C6-ACA856078793}"/>
+              </a:ext>
+            </a:extLst>
+          </p:cNvPr>
+          <p:cNvSpPr/>
+          <p:nvPr/>
+        </p:nvSpPr>
+        <p:spPr>
+          <a:xfrm>
+            <a:off x="6949440" y="5842000"/>
+            <a:ext cx="426720" cy="782320"/>
+          </a:xfrm>
+          <a:prstGeom prst="rightBrace">
+            <a:avLst/>
+          </a:prstGeom>
+        </p:spPr>
+        <p:style>
+          <a:lnRef idx="2">
+            <a:schemeClr val="accent1"/>
+          </a:lnRef>
+          <a:fillRef idx="0">
+            <a:schemeClr val="accent1"/>
+          </a:fillRef>
+          <a:effectRef idx="1">
+            <a:schemeClr val="accent1"/>
+          </a:effectRef>
+          <a:fontRef idx="minor">
+            <a:schemeClr val="tx1"/>
+          </a:fontRef>
+        </p:style>
+        <p:txBody>
+          <a:bodyPr rtlCol="0" anchor="ctr"/>
+          <a:lstStyle/>
+          <a:p>
+            <a:pPr algn="ctr"/>
+            <a:endParaRPr lang="de-DE"/>
+          </a:p>
+        </p:txBody>
+      </p:sp>
+      <p:sp>
+        <p:nvSpPr>
+          <p:cNvPr id="9" name="Textfeld 8">
+            <a:extLst>
+              <a:ext uri="{FF2B5EF4-FFF2-40B4-BE49-F238E27FC236}">
+                <a16:creationId xmlns:a16="http://schemas.microsoft.com/office/drawing/2014/main" id="{755ADA58-317A-EBF7-8E7F-B90B639796D9}"/>
+              </a:ext>
+            </a:extLst>
+          </p:cNvPr>
+          <p:cNvSpPr txBox="1"/>
+          <p:nvPr/>
+        </p:nvSpPr>
+        <p:spPr>
+          <a:xfrm>
+            <a:off x="7457440" y="2519848"/>
+            <a:ext cx="4531365" cy="830997"/>
+          </a:xfrm>
+          <a:prstGeom prst="rect">
+            <a:avLst/>
+          </a:prstGeom>
+          <a:noFill/>
+          <a:ln>
+            <a:solidFill>
+              <a:schemeClr val="tx1"/>
+            </a:solidFill>
+          </a:ln>
+        </p:spPr>
+        <p:txBody>
+          <a:bodyPr wrap="square" rtlCol="0">
+            <a:spAutoFit/>
+          </a:bodyPr>
+          <a:lstStyle/>
+          <a:p>
+            <a:r>
+              <a:rPr lang="de-DE" sz="2400" dirty="0"/>
+              <a:t>PI (</a:t>
+            </a:r>
+            <a:r>
+              <a:rPr lang="de-DE" sz="2400" dirty="0" err="1"/>
+              <a:t>for</a:t>
+            </a:r>
+            <a:r>
+              <a:rPr lang="de-DE" sz="2400" dirty="0"/>
+              <a:t> first-order plant) </a:t>
+            </a:r>
+            <a:r>
+              <a:rPr lang="de-DE" sz="2400" dirty="0" err="1"/>
+              <a:t>or</a:t>
+            </a:r>
+            <a:r>
+              <a:rPr lang="de-DE" sz="2400" dirty="0"/>
+              <a:t> PID (</a:t>
+            </a:r>
+            <a:r>
+              <a:rPr lang="de-DE" sz="2400" dirty="0" err="1"/>
+              <a:t>for</a:t>
+            </a:r>
+            <a:r>
+              <a:rPr lang="de-DE" sz="2400" dirty="0"/>
+              <a:t> </a:t>
+            </a:r>
+            <a:r>
+              <a:rPr lang="de-DE" sz="2400" dirty="0" err="1"/>
+              <a:t>second</a:t>
+            </a:r>
+            <a:r>
+              <a:rPr lang="de-DE" sz="2400" dirty="0"/>
+              <a:t>-order plant) </a:t>
+            </a:r>
+            <a:r>
+              <a:rPr lang="de-DE" sz="2400" dirty="0" err="1"/>
+              <a:t>structure</a:t>
+            </a:r>
+            <a:endParaRPr lang="de-DE" sz="2400" dirty="0"/>
+          </a:p>
+        </p:txBody>
+      </p:sp>
+      <p:cxnSp>
+        <p:nvCxnSpPr>
+          <p:cNvPr id="11" name="Gerade Verbindung mit Pfeil 10">
+            <a:extLst>
+              <a:ext uri="{FF2B5EF4-FFF2-40B4-BE49-F238E27FC236}">
+                <a16:creationId xmlns:a16="http://schemas.microsoft.com/office/drawing/2014/main" id="{F9B4D10C-1B98-212C-4C85-C3BCBC26BA5D}"/>
+              </a:ext>
+            </a:extLst>
+          </p:cNvPr>
+          <p:cNvCxnSpPr>
+            <a:stCxn id="9" idx="0"/>
+          </p:cNvCxnSpPr>
+          <p:nvPr/>
+        </p:nvCxnSpPr>
+        <p:spPr>
+          <a:xfrm flipH="1" flipV="1">
+            <a:off x="9296400" y="2042160"/>
+            <a:ext cx="426723" cy="477688"/>
+          </a:xfrm>
+          <a:prstGeom prst="straightConnector1">
+            <a:avLst/>
+          </a:prstGeom>
+          <a:ln>
+            <a:tailEnd type="triangle"/>
+          </a:ln>
+        </p:spPr>
+        <p:style>
+          <a:lnRef idx="2">
+            <a:schemeClr val="accent1"/>
+          </a:lnRef>
+          <a:fillRef idx="0">
+            <a:schemeClr val="accent1"/>
+          </a:fillRef>
+          <a:effectRef idx="1">
+            <a:schemeClr val="accent1"/>
+          </a:effectRef>
+          <a:fontRef idx="minor">
+            <a:schemeClr val="tx1"/>
+          </a:fontRef>
+        </p:style>
+      </p:cxnSp>
     </p:spTree>
     <p:extLst>
       <p:ext uri="{BB962C8B-B14F-4D97-AF65-F5344CB8AC3E}">
@@ -14014,8 +14526,8 @@
           </a:p>
         </p:txBody>
       </p:sp>
-      <mc:AlternateContent xmlns:mc="http://schemas.openxmlformats.org/markup-compatibility/2006" xmlns:a14="http://schemas.microsoft.com/office/drawing/2010/main">
-        <mc:Choice Requires="a14">
+      <mc:AlternateContent xmlns:mc="http://schemas.openxmlformats.org/markup-compatibility/2006">
+        <mc:Choice xmlns:a14="http://schemas.microsoft.com/office/drawing/2010/main" Requires="a14">
           <p:sp>
             <p:nvSpPr>
               <p:cNvPr id="3" name="Inhaltsplatzhalter 2">
@@ -14035,7 +14547,7 @@
             <p:spPr/>
             <p:txBody>
               <a:bodyPr>
-                <a:normAutofit fontScale="77500" lnSpcReduction="20000"/>
+                <a:normAutofit fontScale="85000" lnSpcReduction="20000"/>
               </a:bodyPr>
               <a:lstStyle/>
               <a:p>
@@ -14449,10 +14961,6 @@
               </a:p>
               <a:p>
                 <a:r>
-                  <a:rPr lang="de-DE" dirty="0"/>
-                  <a:t>Advantage: </a:t>
-                </a:r>
-                <a:r>
                   <a:rPr lang="de-DE" dirty="0" err="1"/>
                   <a:t>direct</a:t>
                 </a:r>
@@ -14491,14 +14999,6 @@
                 <a:endParaRPr lang="de-DE" dirty="0"/>
               </a:p>
               <a:p>
-                <a:r>
-                  <a:rPr lang="de-DE" dirty="0" err="1"/>
-                  <a:t>Limitations</a:t>
-                </a:r>
-                <a:r>
-                  <a:rPr lang="de-DE" dirty="0"/>
-                  <a:t>: </a:t>
-                </a:r>
                 <a:r>
                   <a:rPr lang="de-DE" dirty="0" err="1"/>
                   <a:t>requires</a:t>
@@ -14564,7 +15064,7 @@
             </p:txBody>
           </p:sp>
         </mc:Choice>
-        <mc:Fallback xmlns="">
+        <mc:Fallback>
           <p:sp>
             <p:nvSpPr>
               <p:cNvPr id="3" name="Inhaltsplatzhalter 2">
@@ -14585,7 +15085,7 @@
               <a:blipFill>
                 <a:blip r:embed="rId2"/>
                 <a:stretch>
-                  <a:fillRect l="-844" t="-2616"/>
+                  <a:fillRect l="-965" t="-3198"/>
                 </a:stretch>
               </a:blipFill>
             </p:spPr>
@@ -26234,8 +26734,8 @@
           </a:p>
         </p:txBody>
       </p:sp>
-      <mc:AlternateContent xmlns:mc="http://schemas.openxmlformats.org/markup-compatibility/2006">
-        <mc:Choice xmlns:a14="http://schemas.microsoft.com/office/drawing/2010/main" Requires="a14">
+      <mc:AlternateContent xmlns:mc="http://schemas.openxmlformats.org/markup-compatibility/2006" xmlns:a14="http://schemas.microsoft.com/office/drawing/2010/main">
+        <mc:Choice Requires="a14">
           <p:sp>
             <p:nvSpPr>
               <p:cNvPr id="3" name="Inhaltsplatzhalter 2">
@@ -26568,7 +27068,7 @@
             </p:txBody>
           </p:sp>
         </mc:Choice>
-        <mc:Fallback>
+        <mc:Fallback xmlns="">
           <p:sp>
             <p:nvSpPr>
               <p:cNvPr id="3" name="Inhaltsplatzhalter 2">

</xml_diff>